<commit_message>
feat: add Relational PIM (M5) and delta-mu sensitivity analysis
- Implement RPIM diagnostic (rho1, rho2) comparing PIM vs CWON capital
- Add delta-mu joint sensitivity analysis (delta +/-20%)
- Generate bilingual figures (Fig 6: RPIM, Fig 7: delta sensitivity)
- Create Table 3 with RPIM summary statistics
- Update EN/JA manuscripts with new sections 3.5, 5.5, 5.6
- Update build_docx_pptx.py with Fig 6, Fig 7, Table 3
- Rebuild all docx/pptx outputs

Co-Authored-By: Tatsuki Onishi <bougtoir@gmail.com>
</commit_message>
<xml_diff>
--- a/gdp_tempo_paper/manuscript/figures_en.pptx
+++ b/gdp_tempo_paper/manuscript/figures_en.pptx
@@ -10,6 +10,8 @@
     <p:sldId id="258" r:id="rId9"/>
     <p:sldId id="259" r:id="rId10"/>
     <p:sldId id="260" r:id="rId11"/>
+    <p:sldId id="261" r:id="rId12"/>
+    <p:sldId id="262" r:id="rId13"/>
   </p:sldIdLst>
   <p:sldSz cx="12191695" cy="6858000" type="screen4x3"/>
   <p:notesSz cx="6858000" cy="9144000"/>
@@ -3590,6 +3592,214 @@
                 </a:solidFill>
               </a:rPr>
               <a:t>Conceptual diagram of the population-capital tempo correspondence.</a:t>
+            </a:r>
+          </a:p>
+        </p:txBody>
+      </p:sp>
+    </p:spTree>
+  </p:cSld>
+  <p:clrMapOvr>
+    <a:masterClrMapping/>
+  </p:clrMapOvr>
+</p:sld>
+</file>
+
+<file path=ppt/slides/slide6.xml><?xml version="1.0" encoding="utf-8"?>
+<p:sld xmlns:a="http://schemas.openxmlformats.org/drawingml/2006/main" xmlns:p="http://schemas.openxmlformats.org/presentationml/2006/main" xmlns:r="http://schemas.openxmlformats.org/officeDocument/2006/relationships">
+  <p:cSld>
+    <p:spTree>
+      <p:nvGrpSpPr>
+        <p:cNvPr id="1" name=""/>
+        <p:cNvGrpSpPr/>
+        <p:nvPr/>
+      </p:nvGrpSpPr>
+      <p:grpSpPr/>
+      <p:sp>
+        <p:nvSpPr>
+          <p:cNvPr id="2" name="TextBox 1"/>
+          <p:cNvSpPr txBox="1"/>
+          <p:nvPr/>
+        </p:nvSpPr>
+        <p:spPr>
+          <a:xfrm>
+            <a:off x="365760" y="182880"/>
+            <a:ext cx="11430000" cy="548640"/>
+          </a:xfrm>
+          <a:prstGeom prst="rect">
+            <a:avLst/>
+          </a:prstGeom>
+          <a:noFill/>
+        </p:spPr>
+        <p:txBody>
+          <a:bodyPr wrap="square">
+            <a:spAutoFit/>
+          </a:bodyPr>
+          <a:lstStyle/>
+          <a:p>
+            <a:r>
+              <a:rPr sz="2000" b="1"/>
+              <a:t>Fig. 6. Relational PIM diagnostics: rho_2 across 39 countries under M0 vs M4.</a:t>
+            </a:r>
+          </a:p>
+        </p:txBody>
+      </p:sp>
+      <p:pic>
+        <p:nvPicPr>
+          <p:cNvPr id="3" name="Picture 2" descr="fig6_rpim_en.png"/>
+          <p:cNvPicPr>
+            <a:picLocks noChangeAspect="1"/>
+          </p:cNvPicPr>
+          <p:nvPr/>
+        </p:nvPicPr>
+        <p:blipFill>
+          <a:blip r:embed="rId2"/>
+          <a:stretch>
+            <a:fillRect/>
+          </a:stretch>
+        </p:blipFill>
+        <p:spPr>
+          <a:xfrm>
+            <a:off x="1371600" y="1005840"/>
+            <a:ext cx="9418320" cy="5120640"/>
+          </a:xfrm>
+          <a:prstGeom prst="rect">
+            <a:avLst/>
+          </a:prstGeom>
+        </p:spPr>
+      </p:pic>
+      <p:sp>
+        <p:nvSpPr>
+          <p:cNvPr id="4" name="TextBox 3"/>
+          <p:cNvSpPr txBox="1"/>
+          <p:nvPr/>
+        </p:nvSpPr>
+        <p:spPr>
+          <a:xfrm>
+            <a:off x="365760" y="6263640"/>
+            <a:ext cx="11430000" cy="457200"/>
+          </a:xfrm>
+          <a:prstGeom prst="rect">
+            <a:avLst/>
+          </a:prstGeom>
+          <a:noFill/>
+        </p:spPr>
+        <p:txBody>
+          <a:bodyPr wrap="square">
+            <a:spAutoFit/>
+          </a:bodyPr>
+          <a:lstStyle/>
+          <a:p>
+            <a:r>
+              <a:rPr sz="1400" i="1">
+                <a:solidFill>
+                  <a:srgbClr val="444444"/>
+                </a:solidFill>
+              </a:rPr>
+              <a:t>Relational PIM diagnostics: rho_2 across 39 countries under M0 vs M4.</a:t>
+            </a:r>
+          </a:p>
+        </p:txBody>
+      </p:sp>
+    </p:spTree>
+  </p:cSld>
+  <p:clrMapOvr>
+    <a:masterClrMapping/>
+  </p:clrMapOvr>
+</p:sld>
+</file>
+
+<file path=ppt/slides/slide7.xml><?xml version="1.0" encoding="utf-8"?>
+<p:sld xmlns:a="http://schemas.openxmlformats.org/drawingml/2006/main" xmlns:p="http://schemas.openxmlformats.org/presentationml/2006/main" xmlns:r="http://schemas.openxmlformats.org/officeDocument/2006/relationships">
+  <p:cSld>
+    <p:spTree>
+      <p:nvGrpSpPr>
+        <p:cNvPr id="1" name=""/>
+        <p:cNvGrpSpPr/>
+        <p:nvPr/>
+      </p:nvGrpSpPr>
+      <p:grpSpPr/>
+      <p:sp>
+        <p:nvSpPr>
+          <p:cNvPr id="2" name="TextBox 1"/>
+          <p:cNvSpPr txBox="1"/>
+          <p:nvPr/>
+        </p:nvSpPr>
+        <p:spPr>
+          <a:xfrm>
+            <a:off x="365760" y="182880"/>
+            <a:ext cx="11430000" cy="548640"/>
+          </a:xfrm>
+          <a:prstGeom prst="rect">
+            <a:avLst/>
+          </a:prstGeom>
+          <a:noFill/>
+        </p:spPr>
+        <p:txBody>
+          <a:bodyPr wrap="square">
+            <a:spAutoFit/>
+          </a:bodyPr>
+          <a:lstStyle/>
+          <a:p>
+            <a:r>
+              <a:rPr sz="2000" b="1"/>
+              <a:t>Fig. 7. Delta-mu sensitivity: mu_hat under +/-20% depreciation perturbation.</a:t>
+            </a:r>
+          </a:p>
+        </p:txBody>
+      </p:sp>
+      <p:pic>
+        <p:nvPicPr>
+          <p:cNvPr id="3" name="Picture 2" descr="fig7_delta_sensitivity_en.png"/>
+          <p:cNvPicPr>
+            <a:picLocks noChangeAspect="1"/>
+          </p:cNvPicPr>
+          <p:nvPr/>
+        </p:nvPicPr>
+        <p:blipFill>
+          <a:blip r:embed="rId2"/>
+          <a:stretch>
+            <a:fillRect/>
+          </a:stretch>
+        </p:blipFill>
+        <p:spPr>
+          <a:xfrm>
+            <a:off x="1371600" y="1005840"/>
+            <a:ext cx="9418320" cy="5120640"/>
+          </a:xfrm>
+          <a:prstGeom prst="rect">
+            <a:avLst/>
+          </a:prstGeom>
+        </p:spPr>
+      </p:pic>
+      <p:sp>
+        <p:nvSpPr>
+          <p:cNvPr id="4" name="TextBox 3"/>
+          <p:cNvSpPr txBox="1"/>
+          <p:nvPr/>
+        </p:nvSpPr>
+        <p:spPr>
+          <a:xfrm>
+            <a:off x="365760" y="6263640"/>
+            <a:ext cx="11430000" cy="457200"/>
+          </a:xfrm>
+          <a:prstGeom prst="rect">
+            <a:avLst/>
+          </a:prstGeom>
+          <a:noFill/>
+        </p:spPr>
+        <p:txBody>
+          <a:bodyPr wrap="square">
+            <a:spAutoFit/>
+          </a:bodyPr>
+          <a:lstStyle/>
+          <a:p>
+            <a:r>
+              <a:rPr sz="1400" i="1">
+                <a:solidFill>
+                  <a:srgbClr val="444444"/>
+                </a:solidFill>
+              </a:rPr>
+              <a:t>Delta-mu sensitivity: mu_hat under +/-20% depreciation perturbation.</a:t>
             </a:r>
           </a:p>
         </p:txBody>

</xml_diff>

<commit_message>
feat(gdp_tempo): add conditional OOS, extended OOS metrics, and rho2 cross-sectional regression
Three methodological extensions for Macroeconomic Dynamics submission:

1. Conditional OOS (Section 5.7): Restrict OOS evaluation to 14 interior-
   solution countries where tempo correction is genuinely informative.
   M1 interior median MAPE = 4.23% vs M0 = 4.27%.

2. Extended OOS metrics (Section 5.8, Table 4): Direction accuracy (median
   100% all models) and CWON trajectory RMSE. M2 achieves 15% lower
   trajectory RMSE than M0 (0.0072 vs 0.0085).

3. rho2 cross-sectional regression (Section 5.9, Fig 9): Regress rho2 on
   R&D intensity. M4 slope=0.068, t=2.34 (significant at 5%), R2=0.129.
   Higher R&D intensity associated with better PIM-CWON consistency.

New figures: Fig 8 (conditional OOS bar chart), Fig 9 (rho2 vs R&D scatter).
New table: Table 4 (extended OOS metrics).
All bilingual (EN/JA). Docx/pptx rebuilt.

Co-Authored-By: Tatsuki Onishi <bougtoir@gmail.com>
</commit_message>
<xml_diff>
--- a/gdp_tempo_paper/manuscript/figures_en.pptx
+++ b/gdp_tempo_paper/manuscript/figures_en.pptx
@@ -12,6 +12,8 @@
     <p:sldId id="260" r:id="rId11"/>
     <p:sldId id="261" r:id="rId12"/>
     <p:sldId id="262" r:id="rId13"/>
+    <p:sldId id="263" r:id="rId14"/>
+    <p:sldId id="264" r:id="rId15"/>
   </p:sldIdLst>
   <p:sldSz cx="12191695" cy="6858000" type="screen4x3"/>
   <p:notesSz cx="6858000" cy="9144000"/>
@@ -3800,6 +3802,214 @@
                 </a:solidFill>
               </a:rPr>
               <a:t>Delta-mu sensitivity: mu_hat under +/-20% depreciation perturbation.</a:t>
+            </a:r>
+          </a:p>
+        </p:txBody>
+      </p:sp>
+    </p:spTree>
+  </p:cSld>
+  <p:clrMapOvr>
+    <a:masterClrMapping/>
+  </p:clrMapOvr>
+</p:sld>
+</file>
+
+<file path=ppt/slides/slide8.xml><?xml version="1.0" encoding="utf-8"?>
+<p:sld xmlns:a="http://schemas.openxmlformats.org/drawingml/2006/main" xmlns:p="http://schemas.openxmlformats.org/presentationml/2006/main" xmlns:r="http://schemas.openxmlformats.org/officeDocument/2006/relationships">
+  <p:cSld>
+    <p:spTree>
+      <p:nvGrpSpPr>
+        <p:cNvPr id="1" name=""/>
+        <p:cNvGrpSpPr/>
+        <p:nvPr/>
+      </p:nvGrpSpPr>
+      <p:grpSpPr/>
+      <p:sp>
+        <p:nvSpPr>
+          <p:cNvPr id="2" name="TextBox 1"/>
+          <p:cNvSpPr txBox="1"/>
+          <p:nvPr/>
+        </p:nvSpPr>
+        <p:spPr>
+          <a:xfrm>
+            <a:off x="365760" y="182880"/>
+            <a:ext cx="11430000" cy="548640"/>
+          </a:xfrm>
+          <a:prstGeom prst="rect">
+            <a:avLst/>
+          </a:prstGeom>
+          <a:noFill/>
+        </p:spPr>
+        <p:txBody>
+          <a:bodyPr wrap="square">
+            <a:spAutoFit/>
+          </a:bodyPr>
+          <a:lstStyle/>
+          <a:p>
+            <a:r>
+              <a:rPr sz="2000" b="1"/>
+              <a:t>Fig. 8. Conditional OOS evaluation: interior-solution vs boundary countries.</a:t>
+            </a:r>
+          </a:p>
+        </p:txBody>
+      </p:sp>
+      <p:pic>
+        <p:nvPicPr>
+          <p:cNvPr id="3" name="Picture 2" descr="fig8_conditional_oos_en.png"/>
+          <p:cNvPicPr>
+            <a:picLocks noChangeAspect="1"/>
+          </p:cNvPicPr>
+          <p:nvPr/>
+        </p:nvPicPr>
+        <p:blipFill>
+          <a:blip r:embed="rId2"/>
+          <a:stretch>
+            <a:fillRect/>
+          </a:stretch>
+        </p:blipFill>
+        <p:spPr>
+          <a:xfrm>
+            <a:off x="1371600" y="1005840"/>
+            <a:ext cx="9418320" cy="5120640"/>
+          </a:xfrm>
+          <a:prstGeom prst="rect">
+            <a:avLst/>
+          </a:prstGeom>
+        </p:spPr>
+      </p:pic>
+      <p:sp>
+        <p:nvSpPr>
+          <p:cNvPr id="4" name="TextBox 3"/>
+          <p:cNvSpPr txBox="1"/>
+          <p:nvPr/>
+        </p:nvSpPr>
+        <p:spPr>
+          <a:xfrm>
+            <a:off x="365760" y="6263640"/>
+            <a:ext cx="11430000" cy="457200"/>
+          </a:xfrm>
+          <a:prstGeom prst="rect">
+            <a:avLst/>
+          </a:prstGeom>
+          <a:noFill/>
+        </p:spPr>
+        <p:txBody>
+          <a:bodyPr wrap="square">
+            <a:spAutoFit/>
+          </a:bodyPr>
+          <a:lstStyle/>
+          <a:p>
+            <a:r>
+              <a:rPr sz="1400" i="1">
+                <a:solidFill>
+                  <a:srgbClr val="444444"/>
+                </a:solidFill>
+              </a:rPr>
+              <a:t>Conditional OOS evaluation: interior-solution vs boundary countries.</a:t>
+            </a:r>
+          </a:p>
+        </p:txBody>
+      </p:sp>
+    </p:spTree>
+  </p:cSld>
+  <p:clrMapOvr>
+    <a:masterClrMapping/>
+  </p:clrMapOvr>
+</p:sld>
+</file>
+
+<file path=ppt/slides/slide9.xml><?xml version="1.0" encoding="utf-8"?>
+<p:sld xmlns:a="http://schemas.openxmlformats.org/drawingml/2006/main" xmlns:p="http://schemas.openxmlformats.org/presentationml/2006/main" xmlns:r="http://schemas.openxmlformats.org/officeDocument/2006/relationships">
+  <p:cSld>
+    <p:spTree>
+      <p:nvGrpSpPr>
+        <p:cNvPr id="1" name=""/>
+        <p:cNvGrpSpPr/>
+        <p:nvPr/>
+      </p:nvGrpSpPr>
+      <p:grpSpPr/>
+      <p:sp>
+        <p:nvSpPr>
+          <p:cNvPr id="2" name="TextBox 1"/>
+          <p:cNvSpPr txBox="1"/>
+          <p:nvPr/>
+        </p:nvSpPr>
+        <p:spPr>
+          <a:xfrm>
+            <a:off x="365760" y="182880"/>
+            <a:ext cx="11430000" cy="548640"/>
+          </a:xfrm>
+          <a:prstGeom prst="rect">
+            <a:avLst/>
+          </a:prstGeom>
+          <a:noFill/>
+        </p:spPr>
+        <p:txBody>
+          <a:bodyPr wrap="square">
+            <a:spAutoFit/>
+          </a:bodyPr>
+          <a:lstStyle/>
+          <a:p>
+            <a:r>
+              <a:rPr sz="2000" b="1"/>
+              <a:t>Fig. 9. Cross-sectional regression of rho_2 on R&amp;D intensity.</a:t>
+            </a:r>
+          </a:p>
+        </p:txBody>
+      </p:sp>
+      <p:pic>
+        <p:nvPicPr>
+          <p:cNvPr id="3" name="Picture 2" descr="fig9_rho2_regression_en.png"/>
+          <p:cNvPicPr>
+            <a:picLocks noChangeAspect="1"/>
+          </p:cNvPicPr>
+          <p:nvPr/>
+        </p:nvPicPr>
+        <p:blipFill>
+          <a:blip r:embed="rId2"/>
+          <a:stretch>
+            <a:fillRect/>
+          </a:stretch>
+        </p:blipFill>
+        <p:spPr>
+          <a:xfrm>
+            <a:off x="1371600" y="1005840"/>
+            <a:ext cx="9418320" cy="5120640"/>
+          </a:xfrm>
+          <a:prstGeom prst="rect">
+            <a:avLst/>
+          </a:prstGeom>
+        </p:spPr>
+      </p:pic>
+      <p:sp>
+        <p:nvSpPr>
+          <p:cNvPr id="4" name="TextBox 3"/>
+          <p:cNvSpPr txBox="1"/>
+          <p:nvPr/>
+        </p:nvSpPr>
+        <p:spPr>
+          <a:xfrm>
+            <a:off x="365760" y="6263640"/>
+            <a:ext cx="11430000" cy="457200"/>
+          </a:xfrm>
+          <a:prstGeom prst="rect">
+            <a:avLst/>
+          </a:prstGeom>
+          <a:noFill/>
+        </p:spPr>
+        <p:txBody>
+          <a:bodyPr wrap="square">
+            <a:spAutoFit/>
+          </a:bodyPr>
+          <a:lstStyle/>
+          <a:p>
+            <a:r>
+              <a:rPr sz="1400" i="1">
+                <a:solidFill>
+                  <a:srgbClr val="444444"/>
+                </a:solidFill>
+              </a:rPr>
+              <a:t>Cross-sectional regression of rho_2 on R&amp;D intensity.</a:t>
             </a:r>
           </a:p>
         </p:txBody>

</xml_diff>

<commit_message>
feat(economica): Solow decomposition, counterfactual wealth, Economica reframing
- Add solow_decomposition.py: TFP under M0/M2/M4 for all 39 countries,
  tempo-artifact variance decomposition (Table 5), counterfactual wealth
  comparing CWON official vs beta-adjusted (Fig 11)
- Reframe manuscript title/abstract/intro as 'economic discovery' not
  'method transplantation' (Solow residual focus)
- Add Sections 5.10 (Solow decomposition) and 5.11 (counterfactual wealth)
  to both EN and JA manuscripts
- Update cover letter for Economica editors (Besley, den Haan, et al.)
- Update build_docx_pptx.py: Economica docstring, Fig 10-11, Table 5
- Regenerate all docx/pptx outputs with 11 figures and 5 tables
- New data: solow_decomposition.csv, counterfactual_wealth.csv,
  table5_tempo_artifact.csv
- New figures: fig10 (Solow decomp, EN/JA), fig11 (wealth, EN/JA)

Co-Authored-By: Tatsuki Onishi <bougtoir@gmail.com>
</commit_message>
<xml_diff>
--- a/gdp_tempo_paper/manuscript/figures_en.pptx
+++ b/gdp_tempo_paper/manuscript/figures_en.pptx
@@ -14,6 +14,8 @@
     <p:sldId id="262" r:id="rId13"/>
     <p:sldId id="263" r:id="rId14"/>
     <p:sldId id="264" r:id="rId15"/>
+    <p:sldId id="265" r:id="rId16"/>
+    <p:sldId id="266" r:id="rId17"/>
   </p:sldIdLst>
   <p:sldSz cx="12191695" cy="6858000" type="screen4x3"/>
   <p:notesSz cx="6858000" cy="9144000"/>
@@ -3178,6 +3180,214 @@
                 </a:solidFill>
               </a:rPr>
               <a:t>In-sample 1-year GDP growth RMSE across M0-M4 for 39 countries (lower is better).</a:t>
+            </a:r>
+          </a:p>
+        </p:txBody>
+      </p:sp>
+    </p:spTree>
+  </p:cSld>
+  <p:clrMapOvr>
+    <a:masterClrMapping/>
+  </p:clrMapOvr>
+</p:sld>
+</file>
+
+<file path=ppt/slides/slide10.xml><?xml version="1.0" encoding="utf-8"?>
+<p:sld xmlns:a="http://schemas.openxmlformats.org/drawingml/2006/main" xmlns:p="http://schemas.openxmlformats.org/presentationml/2006/main" xmlns:r="http://schemas.openxmlformats.org/officeDocument/2006/relationships">
+  <p:cSld>
+    <p:spTree>
+      <p:nvGrpSpPr>
+        <p:cNvPr id="1" name=""/>
+        <p:cNvGrpSpPr/>
+        <p:nvPr/>
+      </p:nvGrpSpPr>
+      <p:grpSpPr/>
+      <p:sp>
+        <p:nvSpPr>
+          <p:cNvPr id="2" name="TextBox 1"/>
+          <p:cNvSpPr txBox="1"/>
+          <p:nvPr/>
+        </p:nvSpPr>
+        <p:spPr>
+          <a:xfrm>
+            <a:off x="365760" y="182880"/>
+            <a:ext cx="11430000" cy="548640"/>
+          </a:xfrm>
+          <a:prstGeom prst="rect">
+            <a:avLst/>
+          </a:prstGeom>
+          <a:noFill/>
+        </p:spPr>
+        <p:txBody>
+          <a:bodyPr wrap="square">
+            <a:spAutoFit/>
+          </a:bodyPr>
+          <a:lstStyle/>
+          <a:p>
+            <a:r>
+              <a:rPr sz="2000" b="1"/>
+              <a:t>Fig. 10. Solow-residual decomposition: M0 vs tempo-adjusted (M2) vs joint (M4) for six representative countries.</a:t>
+            </a:r>
+          </a:p>
+        </p:txBody>
+      </p:sp>
+      <p:pic>
+        <p:nvPicPr>
+          <p:cNvPr id="3" name="Picture 2" descr="fig10_solow_decomp_en.png"/>
+          <p:cNvPicPr>
+            <a:picLocks noChangeAspect="1"/>
+          </p:cNvPicPr>
+          <p:nvPr/>
+        </p:nvPicPr>
+        <p:blipFill>
+          <a:blip r:embed="rId2"/>
+          <a:stretch>
+            <a:fillRect/>
+          </a:stretch>
+        </p:blipFill>
+        <p:spPr>
+          <a:xfrm>
+            <a:off x="1371600" y="1005840"/>
+            <a:ext cx="9418320" cy="5120640"/>
+          </a:xfrm>
+          <a:prstGeom prst="rect">
+            <a:avLst/>
+          </a:prstGeom>
+        </p:spPr>
+      </p:pic>
+      <p:sp>
+        <p:nvSpPr>
+          <p:cNvPr id="4" name="TextBox 3"/>
+          <p:cNvSpPr txBox="1"/>
+          <p:nvPr/>
+        </p:nvSpPr>
+        <p:spPr>
+          <a:xfrm>
+            <a:off x="365760" y="6263640"/>
+            <a:ext cx="11430000" cy="457200"/>
+          </a:xfrm>
+          <a:prstGeom prst="rect">
+            <a:avLst/>
+          </a:prstGeom>
+          <a:noFill/>
+        </p:spPr>
+        <p:txBody>
+          <a:bodyPr wrap="square">
+            <a:spAutoFit/>
+          </a:bodyPr>
+          <a:lstStyle/>
+          <a:p>
+            <a:r>
+              <a:rPr sz="1400" i="1">
+                <a:solidFill>
+                  <a:srgbClr val="444444"/>
+                </a:solidFill>
+              </a:rPr>
+              <a:t>Solow-residual decomposition: M0 vs tempo-adjusted (M2) vs joint (M4) for six representative countries.</a:t>
+            </a:r>
+          </a:p>
+        </p:txBody>
+      </p:sp>
+    </p:spTree>
+  </p:cSld>
+  <p:clrMapOvr>
+    <a:masterClrMapping/>
+  </p:clrMapOvr>
+</p:sld>
+</file>
+
+<file path=ppt/slides/slide11.xml><?xml version="1.0" encoding="utf-8"?>
+<p:sld xmlns:a="http://schemas.openxmlformats.org/drawingml/2006/main" xmlns:p="http://schemas.openxmlformats.org/presentationml/2006/main" xmlns:r="http://schemas.openxmlformats.org/officeDocument/2006/relationships">
+  <p:cSld>
+    <p:spTree>
+      <p:nvGrpSpPr>
+        <p:cNvPr id="1" name=""/>
+        <p:cNvGrpSpPr/>
+        <p:nvPr/>
+      </p:nvGrpSpPr>
+      <p:grpSpPr/>
+      <p:sp>
+        <p:nvSpPr>
+          <p:cNvPr id="2" name="TextBox 1"/>
+          <p:cNvSpPr txBox="1"/>
+          <p:nvPr/>
+        </p:nvSpPr>
+        <p:spPr>
+          <a:xfrm>
+            <a:off x="365760" y="182880"/>
+            <a:ext cx="11430000" cy="548640"/>
+          </a:xfrm>
+          <a:prstGeom prst="rect">
+            <a:avLst/>
+          </a:prstGeom>
+          <a:noFill/>
+        </p:spPr>
+        <p:txBody>
+          <a:bodyPr wrap="square">
+            <a:spAutoFit/>
+          </a:bodyPr>
+          <a:lstStyle/>
+          <a:p>
+            <a:r>
+              <a:rPr sz="2000" b="1"/>
+              <a:t>Fig. 11. National wealth: CWON official vs intangible-adjusted produced capital (2019).</a:t>
+            </a:r>
+          </a:p>
+        </p:txBody>
+      </p:sp>
+      <p:pic>
+        <p:nvPicPr>
+          <p:cNvPr id="3" name="Picture 2" descr="fig11_counterfactual_wealth_en.png"/>
+          <p:cNvPicPr>
+            <a:picLocks noChangeAspect="1"/>
+          </p:cNvPicPr>
+          <p:nvPr/>
+        </p:nvPicPr>
+        <p:blipFill>
+          <a:blip r:embed="rId2"/>
+          <a:stretch>
+            <a:fillRect/>
+          </a:stretch>
+        </p:blipFill>
+        <p:spPr>
+          <a:xfrm>
+            <a:off x="1371600" y="1005840"/>
+            <a:ext cx="9418320" cy="5120640"/>
+          </a:xfrm>
+          <a:prstGeom prst="rect">
+            <a:avLst/>
+          </a:prstGeom>
+        </p:spPr>
+      </p:pic>
+      <p:sp>
+        <p:nvSpPr>
+          <p:cNvPr id="4" name="TextBox 3"/>
+          <p:cNvSpPr txBox="1"/>
+          <p:nvPr/>
+        </p:nvSpPr>
+        <p:spPr>
+          <a:xfrm>
+            <a:off x="365760" y="6263640"/>
+            <a:ext cx="11430000" cy="457200"/>
+          </a:xfrm>
+          <a:prstGeom prst="rect">
+            <a:avLst/>
+          </a:prstGeom>
+          <a:noFill/>
+        </p:spPr>
+        <p:txBody>
+          <a:bodyPr wrap="square">
+            <a:spAutoFit/>
+          </a:bodyPr>
+          <a:lstStyle/>
+          <a:p>
+            <a:r>
+              <a:rPr sz="1400" i="1">
+                <a:solidFill>
+                  <a:srgbClr val="444444"/>
+                </a:solidFill>
+              </a:rPr>
+              <a:t>National wealth: CWON official vs intangible-adjusted produced capital (2019).</a:t>
             </a:r>
           </a:p>
         </p:txBody>

</xml_diff>

<commit_message>
JoM submission: Introduction強化 + Policy implications具体化 + double-blind format
- Rewrite Introduction for macro audience: emphasize tempo effect novelty
  for fiscal/monetary policy, connect to output gap and DSGE calibration
- Add concrete Section 6.4 policy implications: potential output & fiscal
  rules, monetary-policy transmission lags, SNA statistical-agency practice,
  international GDP comparability
- Double-blind format: separate title page with author info from anonymized
  manuscript body; add Highlights (5 bullets, all ≤85 chars)
- Update cover letter for Journal of Macroeconomics editor
- Build script: handle title-page/manuscript markers, dash-bullet highlights,
  generate title_page_en.docx/pdf
- Add Havranek & Rusnak (2013) reference for monetary transmission lags
- Sync workflow: add JoM branch mapping to gdp-tempo-paper public repo
- Regenerate all outputs: manuscript docx/pdf, figures pptx, tables, cover letter

Co-Authored-By: Tatsuki Onishi <bougtoir@gmail.com>
</commit_message>
<xml_diff>
--- a/gdp_tempo_paper/manuscript/figures_en.pptx
+++ b/gdp_tempo_paper/manuscript/figures_en.pptx
@@ -3122,14 +3122,14 @@
           <a:p>
             <a:r>
               <a:rPr sz="2000" b="1"/>
-              <a:t>Fig. 1. In-sample 1-year GDP growth RMSE across M0-M4 for 39 countries (lower is better).</a:t>
+              <a:t>Fig. 1. PIM stock K_tang+betaK_I versus CWON PCA (within-country demeaned log).</a:t>
             </a:r>
           </a:p>
         </p:txBody>
       </p:sp>
       <p:pic>
         <p:nvPicPr>
-          <p:cNvPr id="3" name="Picture 2" descr="fig1_m_ranking_en.png"/>
+          <p:cNvPr id="3" name="Picture 2" descr="fig3_trajectories_en.png"/>
           <p:cNvPicPr>
             <a:picLocks noChangeAspect="1"/>
           </p:cNvPicPr>
@@ -3179,7 +3179,7 @@
                   <a:srgbClr val="444444"/>
                 </a:solidFill>
               </a:rPr>
-              <a:t>In-sample 1-year GDP growth RMSE across M0-M4 for 39 countries (lower is better).</a:t>
+              <a:t>PIM stock K_tang+betaK_I versus CWON PCA (within-country demeaned log).</a:t>
             </a:r>
           </a:p>
         </p:txBody>
@@ -3434,14 +3434,14 @@
           <a:p>
             <a:r>
               <a:rPr sz="2000" b="1"/>
-              <a:t>Fig. 2. Out-of-sample MAPE on 2015-19 held-out window; M2 achieves 13% relative improvement vs M0.</a:t>
+              <a:t>Fig. 2. In-sample 1-year GDP growth RMSE across M0-M4 for 39 countries (lower is better).</a:t>
             </a:r>
           </a:p>
         </p:txBody>
       </p:sp>
       <p:pic>
         <p:nvPicPr>
-          <p:cNvPr id="3" name="Picture 2" descr="fig2_oos_en.png"/>
+          <p:cNvPr id="3" name="Picture 2" descr="fig1_m_ranking_en.png"/>
           <p:cNvPicPr>
             <a:picLocks noChangeAspect="1"/>
           </p:cNvPicPr>
@@ -3491,7 +3491,7 @@
                   <a:srgbClr val="444444"/>
                 </a:solidFill>
               </a:rPr>
-              <a:t>Out-of-sample MAPE on 2015-19 held-out window; M2 achieves 13% relative improvement vs M0.</a:t>
+              <a:t>In-sample 1-year GDP growth RMSE across M0-M4 for 39 countries (lower is better).</a:t>
             </a:r>
           </a:p>
         </p:txBody>
@@ -3538,14 +3538,14 @@
           <a:p>
             <a:r>
               <a:rPr sz="2000" b="1"/>
-              <a:t>Fig. 3. PIM stock K_tang+betaK_I versus CWON PCA (within-country demeaned log).</a:t>
+              <a:t>Fig. 3. Out-of-sample MAPE on 2015-19 held-out window; M2 achieves 13% relative improvement vs M0.</a:t>
             </a:r>
           </a:p>
         </p:txBody>
       </p:sp>
       <p:pic>
         <p:nvPicPr>
-          <p:cNvPr id="3" name="Picture 2" descr="fig3_trajectories_en.png"/>
+          <p:cNvPr id="3" name="Picture 2" descr="fig2_oos_en.png"/>
           <p:cNvPicPr>
             <a:picLocks noChangeAspect="1"/>
           </p:cNvPicPr>
@@ -3595,7 +3595,7 @@
                   <a:srgbClr val="444444"/>
                 </a:solidFill>
               </a:rPr>
-              <a:t>PIM stock K_tang+betaK_I versus CWON PCA (within-country demeaned log).</a:t>
+              <a:t>Out-of-sample MAPE on 2015-19 held-out window; M2 achieves 13% relative improvement vs M0.</a:t>
             </a:r>
           </a:p>
         </p:txBody>

</xml_diff>

<commit_message>
fix: renumber figures 1-3 to match order of first appearance
Old Figure 2 (RMSE ranking) → Figure 1 (first placed in §5.2)
Old Figure 3 (OOS MAPE) → Figure 2 (second placed in §5.2)
Old Figure 1 (PIM vs CWON) → Figure 3 (placed in §5.3)
Figures 4-11 and Tables 1-5 unchanged (already sequential).
Updated FIG_LIST in build script and rebuilt all outputs.

Co-Authored-By: Tatsuki Onishi <bougtoir@gmail.com>
</commit_message>
<xml_diff>
--- a/gdp_tempo_paper/manuscript/figures_en.pptx
+++ b/gdp_tempo_paper/manuscript/figures_en.pptx
@@ -3122,14 +3122,14 @@
           <a:p>
             <a:r>
               <a:rPr sz="2000" b="1"/>
-              <a:t>Fig. 1. PIM stock K_tang+betaK_I versus CWON PCA (within-country demeaned log).</a:t>
+              <a:t>Fig. 1. In-sample 1-year GDP growth RMSE across M0-M4 for 39 countries (lower is better).</a:t>
             </a:r>
           </a:p>
         </p:txBody>
       </p:sp>
       <p:pic>
         <p:nvPicPr>
-          <p:cNvPr id="3" name="Picture 2" descr="fig3_trajectories_en.png"/>
+          <p:cNvPr id="3" name="Picture 2" descr="fig1_m_ranking_en.png"/>
           <p:cNvPicPr>
             <a:picLocks noChangeAspect="1"/>
           </p:cNvPicPr>
@@ -3179,7 +3179,7 @@
                   <a:srgbClr val="444444"/>
                 </a:solidFill>
               </a:rPr>
-              <a:t>PIM stock K_tang+betaK_I versus CWON PCA (within-country demeaned log).</a:t>
+              <a:t>In-sample 1-year GDP growth RMSE across M0-M4 for 39 countries (lower is better).</a:t>
             </a:r>
           </a:p>
         </p:txBody>
@@ -3434,14 +3434,14 @@
           <a:p>
             <a:r>
               <a:rPr sz="2000" b="1"/>
-              <a:t>Fig. 2. In-sample 1-year GDP growth RMSE across M0-M4 for 39 countries (lower is better).</a:t>
+              <a:t>Fig. 2. Out-of-sample MAPE on 2015-19 held-out window; M2 achieves 13% relative improvement vs M0.</a:t>
             </a:r>
           </a:p>
         </p:txBody>
       </p:sp>
       <p:pic>
         <p:nvPicPr>
-          <p:cNvPr id="3" name="Picture 2" descr="fig1_m_ranking_en.png"/>
+          <p:cNvPr id="3" name="Picture 2" descr="fig2_oos_en.png"/>
           <p:cNvPicPr>
             <a:picLocks noChangeAspect="1"/>
           </p:cNvPicPr>
@@ -3491,7 +3491,7 @@
                   <a:srgbClr val="444444"/>
                 </a:solidFill>
               </a:rPr>
-              <a:t>In-sample 1-year GDP growth RMSE across M0-M4 for 39 countries (lower is better).</a:t>
+              <a:t>Out-of-sample MAPE on 2015-19 held-out window; M2 achieves 13% relative improvement vs M0.</a:t>
             </a:r>
           </a:p>
         </p:txBody>
@@ -3538,14 +3538,14 @@
           <a:p>
             <a:r>
               <a:rPr sz="2000" b="1"/>
-              <a:t>Fig. 3. Out-of-sample MAPE on 2015-19 held-out window; M2 achieves 13% relative improvement vs M0.</a:t>
+              <a:t>Fig. 3. PIM stock K_tang+betaK_I versus CWON PCA (within-country demeaned log).</a:t>
             </a:r>
           </a:p>
         </p:txBody>
       </p:sp>
       <p:pic>
         <p:nvPicPr>
-          <p:cNvPr id="3" name="Picture 2" descr="fig2_oos_en.png"/>
+          <p:cNvPr id="3" name="Picture 2" descr="fig3_trajectories_en.png"/>
           <p:cNvPicPr>
             <a:picLocks noChangeAspect="1"/>
           </p:cNvPicPr>
@@ -3595,7 +3595,7 @@
                   <a:srgbClr val="444444"/>
                 </a:solidFill>
               </a:rPr>
-              <a:t>Out-of-sample MAPE on 2015-19 held-out window; M2 achieves 13% relative improvement vs M0.</a:t>
+              <a:t>PIM stock K_tang+betaK_I versus CWON PCA (within-country demeaned log).</a:t>
             </a:r>
           </a:p>
         </p:txBody>

</xml_diff>

<commit_message>
Revise GDP-Tempo manuscript for Empirical Economics submission
Key changes:
- Integrate K-level measurement consequences (Section 5.10): K_obs < K_M0
  for all 35 countries (median -4.3%), shifting TFP by 1.7pp and labour
  share by 1.7pp — directly addressing Inklaar's measurement critique
- Add observable parameter-free tempo proxy M_obs as 6th model (Section 4.2)
- Reframe abstract/introduction to lead with K-level findings
- Add 3 new figures (10-12: K divergence, TFP consequence, labour share)
- Renumber old figs 10-11 to 13-14 for sequential citation order
- Add Table 6 (K-level measurement consequences, 35 countries)
- Add Karabarbounis & Neiman (2014) reference for labour-share context
- Update cover letters (EN/JA) for Empirical Economics with K-level framing
- Update build script for 14 figures, 6 tables, Empirical Economics format
- Regenerate all outputs: docx, pptx, pdf, standalone table docx files

Co-Authored-By: Tatsuki Onishi <bougtoir@gmail.com>
</commit_message>
<xml_diff>
--- a/gdp_tempo_paper/manuscript/figures_en.pptx
+++ b/gdp_tempo_paper/manuscript/figures_en.pptx
@@ -16,6 +16,9 @@
     <p:sldId id="264" r:id="rId15"/>
     <p:sldId id="265" r:id="rId16"/>
     <p:sldId id="266" r:id="rId17"/>
+    <p:sldId id="267" r:id="rId18"/>
+    <p:sldId id="268" r:id="rId19"/>
+    <p:sldId id="269" r:id="rId20"/>
   </p:sldIdLst>
   <p:sldSz cx="12191695" cy="6858000" type="screen4x3"/>
   <p:notesSz cx="6858000" cy="9144000"/>
@@ -3226,14 +3229,14 @@
           <a:p>
             <a:r>
               <a:rPr sz="2000" b="1"/>
-              <a:t>Fig. 10. Solow-residual decomposition: M0 vs tempo-adjusted (M2) vs joint (M4) for six representative countries.</a:t>
+              <a:t>Fig. 10. Capital-stock divergence: K_obs vs K_M0 over time for six representative countries.</a:t>
             </a:r>
           </a:p>
         </p:txBody>
       </p:sp>
       <p:pic>
         <p:nvPicPr>
-          <p:cNvPr id="3" name="Picture 2" descr="fig10_solow_decomp_en.png"/>
+          <p:cNvPr id="3" name="Picture 2" descr="fig10_k_divergence_en.png"/>
           <p:cNvPicPr>
             <a:picLocks noChangeAspect="1"/>
           </p:cNvPicPr>
@@ -3283,7 +3286,7 @@
                   <a:srgbClr val="444444"/>
                 </a:solidFill>
               </a:rPr>
-              <a:t>Solow-residual decomposition: M0 vs tempo-adjusted (M2) vs joint (M4) for six representative countries.</a:t>
+              <a:t>Capital-stock divergence: K_obs vs K_M0 over time for six representative countries.</a:t>
             </a:r>
           </a:p>
         </p:txBody>
@@ -3330,14 +3333,326 @@
           <a:p>
             <a:r>
               <a:rPr sz="2000" b="1"/>
-              <a:t>Fig. 11. National wealth: CWON official vs intangible-adjusted produced capital (2019).</a:t>
+              <a:t>Fig. 11. Measurement consequence: K-level change vs TFP shift (country means, 2010-2019).</a:t>
             </a:r>
           </a:p>
         </p:txBody>
       </p:sp>
       <p:pic>
         <p:nvPicPr>
-          <p:cNvPr id="3" name="Picture 2" descr="fig11_counterfactual_wealth_en.png"/>
+          <p:cNvPr id="3" name="Picture 2" descr="fig11_tfp_consequence_en.png"/>
+          <p:cNvPicPr>
+            <a:picLocks noChangeAspect="1"/>
+          </p:cNvPicPr>
+          <p:nvPr/>
+        </p:nvPicPr>
+        <p:blipFill>
+          <a:blip r:embed="rId2"/>
+          <a:stretch>
+            <a:fillRect/>
+          </a:stretch>
+        </p:blipFill>
+        <p:spPr>
+          <a:xfrm>
+            <a:off x="1371600" y="1005840"/>
+            <a:ext cx="9418320" cy="5120640"/>
+          </a:xfrm>
+          <a:prstGeom prst="rect">
+            <a:avLst/>
+          </a:prstGeom>
+        </p:spPr>
+      </p:pic>
+      <p:sp>
+        <p:nvSpPr>
+          <p:cNvPr id="4" name="TextBox 3"/>
+          <p:cNvSpPr txBox="1"/>
+          <p:nvPr/>
+        </p:nvSpPr>
+        <p:spPr>
+          <a:xfrm>
+            <a:off x="365760" y="6263640"/>
+            <a:ext cx="11430000" cy="457200"/>
+          </a:xfrm>
+          <a:prstGeom prst="rect">
+            <a:avLst/>
+          </a:prstGeom>
+          <a:noFill/>
+        </p:spPr>
+        <p:txBody>
+          <a:bodyPr wrap="square">
+            <a:spAutoFit/>
+          </a:bodyPr>
+          <a:lstStyle/>
+          <a:p>
+            <a:r>
+              <a:rPr sz="1400" i="1">
+                <a:solidFill>
+                  <a:srgbClr val="444444"/>
+                </a:solidFill>
+              </a:rPr>
+              <a:t>Measurement consequence: K-level change vs TFP shift (country means, 2010-2019).</a:t>
+            </a:r>
+          </a:p>
+        </p:txBody>
+      </p:sp>
+    </p:spTree>
+  </p:cSld>
+  <p:clrMapOvr>
+    <a:masterClrMapping/>
+  </p:clrMapOvr>
+</p:sld>
+</file>
+
+<file path=ppt/slides/slide12.xml><?xml version="1.0" encoding="utf-8"?>
+<p:sld xmlns:a="http://schemas.openxmlformats.org/drawingml/2006/main" xmlns:p="http://schemas.openxmlformats.org/presentationml/2006/main" xmlns:r="http://schemas.openxmlformats.org/officeDocument/2006/relationships">
+  <p:cSld>
+    <p:spTree>
+      <p:nvGrpSpPr>
+        <p:cNvPr id="1" name=""/>
+        <p:cNvGrpSpPr/>
+        <p:nvPr/>
+      </p:nvGrpSpPr>
+      <p:grpSpPr/>
+      <p:sp>
+        <p:nvSpPr>
+          <p:cNvPr id="2" name="TextBox 1"/>
+          <p:cNvSpPr txBox="1"/>
+          <p:nvPr/>
+        </p:nvSpPr>
+        <p:spPr>
+          <a:xfrm>
+            <a:off x="365760" y="182880"/>
+            <a:ext cx="11430000" cy="548640"/>
+          </a:xfrm>
+          <a:prstGeom prst="rect">
+            <a:avLst/>
+          </a:prstGeom>
+          <a:noFill/>
+        </p:spPr>
+        <p:txBody>
+          <a:bodyPr wrap="square">
+            <a:spAutoFit/>
+          </a:bodyPr>
+          <a:lstStyle/>
+          <a:p>
+            <a:r>
+              <a:rPr sz="2000" b="1"/>
+              <a:t>Fig. 12. Implied labour-share correction from tempo-adjusted capital (country means, 2010-2019).</a:t>
+            </a:r>
+          </a:p>
+        </p:txBody>
+      </p:sp>
+      <p:pic>
+        <p:nvPicPr>
+          <p:cNvPr id="3" name="Picture 2" descr="fig12_labor_share_en.png"/>
+          <p:cNvPicPr>
+            <a:picLocks noChangeAspect="1"/>
+          </p:cNvPicPr>
+          <p:nvPr/>
+        </p:nvPicPr>
+        <p:blipFill>
+          <a:blip r:embed="rId2"/>
+          <a:stretch>
+            <a:fillRect/>
+          </a:stretch>
+        </p:blipFill>
+        <p:spPr>
+          <a:xfrm>
+            <a:off x="1371600" y="1005840"/>
+            <a:ext cx="9418320" cy="5120640"/>
+          </a:xfrm>
+          <a:prstGeom prst="rect">
+            <a:avLst/>
+          </a:prstGeom>
+        </p:spPr>
+      </p:pic>
+      <p:sp>
+        <p:nvSpPr>
+          <p:cNvPr id="4" name="TextBox 3"/>
+          <p:cNvSpPr txBox="1"/>
+          <p:nvPr/>
+        </p:nvSpPr>
+        <p:spPr>
+          <a:xfrm>
+            <a:off x="365760" y="6263640"/>
+            <a:ext cx="11430000" cy="457200"/>
+          </a:xfrm>
+          <a:prstGeom prst="rect">
+            <a:avLst/>
+          </a:prstGeom>
+          <a:noFill/>
+        </p:spPr>
+        <p:txBody>
+          <a:bodyPr wrap="square">
+            <a:spAutoFit/>
+          </a:bodyPr>
+          <a:lstStyle/>
+          <a:p>
+            <a:r>
+              <a:rPr sz="1400" i="1">
+                <a:solidFill>
+                  <a:srgbClr val="444444"/>
+                </a:solidFill>
+              </a:rPr>
+              <a:t>Implied labour-share correction from tempo-adjusted capital (country means, 2010-2019).</a:t>
+            </a:r>
+          </a:p>
+        </p:txBody>
+      </p:sp>
+    </p:spTree>
+  </p:cSld>
+  <p:clrMapOvr>
+    <a:masterClrMapping/>
+  </p:clrMapOvr>
+</p:sld>
+</file>
+
+<file path=ppt/slides/slide13.xml><?xml version="1.0" encoding="utf-8"?>
+<p:sld xmlns:a="http://schemas.openxmlformats.org/drawingml/2006/main" xmlns:p="http://schemas.openxmlformats.org/presentationml/2006/main" xmlns:r="http://schemas.openxmlformats.org/officeDocument/2006/relationships">
+  <p:cSld>
+    <p:spTree>
+      <p:nvGrpSpPr>
+        <p:cNvPr id="1" name=""/>
+        <p:cNvGrpSpPr/>
+        <p:nvPr/>
+      </p:nvGrpSpPr>
+      <p:grpSpPr/>
+      <p:sp>
+        <p:nvSpPr>
+          <p:cNvPr id="2" name="TextBox 1"/>
+          <p:cNvSpPr txBox="1"/>
+          <p:nvPr/>
+        </p:nvSpPr>
+        <p:spPr>
+          <a:xfrm>
+            <a:off x="365760" y="182880"/>
+            <a:ext cx="11430000" cy="548640"/>
+          </a:xfrm>
+          <a:prstGeom prst="rect">
+            <a:avLst/>
+          </a:prstGeom>
+          <a:noFill/>
+        </p:spPr>
+        <p:txBody>
+          <a:bodyPr wrap="square">
+            <a:spAutoFit/>
+          </a:bodyPr>
+          <a:lstStyle/>
+          <a:p>
+            <a:r>
+              <a:rPr sz="2000" b="1"/>
+              <a:t>Fig. 13. Solow-residual decomposition: M0 vs tempo-adjusted (M2) vs joint (M4) for six representative countries.</a:t>
+            </a:r>
+          </a:p>
+        </p:txBody>
+      </p:sp>
+      <p:pic>
+        <p:nvPicPr>
+          <p:cNvPr id="3" name="Picture 2" descr="fig13_solow_decomp_en.png"/>
+          <p:cNvPicPr>
+            <a:picLocks noChangeAspect="1"/>
+          </p:cNvPicPr>
+          <p:nvPr/>
+        </p:nvPicPr>
+        <p:blipFill>
+          <a:blip r:embed="rId2"/>
+          <a:stretch>
+            <a:fillRect/>
+          </a:stretch>
+        </p:blipFill>
+        <p:spPr>
+          <a:xfrm>
+            <a:off x="1371600" y="1005840"/>
+            <a:ext cx="9418320" cy="5120640"/>
+          </a:xfrm>
+          <a:prstGeom prst="rect">
+            <a:avLst/>
+          </a:prstGeom>
+        </p:spPr>
+      </p:pic>
+      <p:sp>
+        <p:nvSpPr>
+          <p:cNvPr id="4" name="TextBox 3"/>
+          <p:cNvSpPr txBox="1"/>
+          <p:nvPr/>
+        </p:nvSpPr>
+        <p:spPr>
+          <a:xfrm>
+            <a:off x="365760" y="6263640"/>
+            <a:ext cx="11430000" cy="457200"/>
+          </a:xfrm>
+          <a:prstGeom prst="rect">
+            <a:avLst/>
+          </a:prstGeom>
+          <a:noFill/>
+        </p:spPr>
+        <p:txBody>
+          <a:bodyPr wrap="square">
+            <a:spAutoFit/>
+          </a:bodyPr>
+          <a:lstStyle/>
+          <a:p>
+            <a:r>
+              <a:rPr sz="1400" i="1">
+                <a:solidFill>
+                  <a:srgbClr val="444444"/>
+                </a:solidFill>
+              </a:rPr>
+              <a:t>Solow-residual decomposition: M0 vs tempo-adjusted (M2) vs joint (M4) for six representative countries.</a:t>
+            </a:r>
+          </a:p>
+        </p:txBody>
+      </p:sp>
+    </p:spTree>
+  </p:cSld>
+  <p:clrMapOvr>
+    <a:masterClrMapping/>
+  </p:clrMapOvr>
+</p:sld>
+</file>
+
+<file path=ppt/slides/slide14.xml><?xml version="1.0" encoding="utf-8"?>
+<p:sld xmlns:a="http://schemas.openxmlformats.org/drawingml/2006/main" xmlns:p="http://schemas.openxmlformats.org/presentationml/2006/main" xmlns:r="http://schemas.openxmlformats.org/officeDocument/2006/relationships">
+  <p:cSld>
+    <p:spTree>
+      <p:nvGrpSpPr>
+        <p:cNvPr id="1" name=""/>
+        <p:cNvGrpSpPr/>
+        <p:nvPr/>
+      </p:nvGrpSpPr>
+      <p:grpSpPr/>
+      <p:sp>
+        <p:nvSpPr>
+          <p:cNvPr id="2" name="TextBox 1"/>
+          <p:cNvSpPr txBox="1"/>
+          <p:nvPr/>
+        </p:nvSpPr>
+        <p:spPr>
+          <a:xfrm>
+            <a:off x="365760" y="182880"/>
+            <a:ext cx="11430000" cy="548640"/>
+          </a:xfrm>
+          <a:prstGeom prst="rect">
+            <a:avLst/>
+          </a:prstGeom>
+          <a:noFill/>
+        </p:spPr>
+        <p:txBody>
+          <a:bodyPr wrap="square">
+            <a:spAutoFit/>
+          </a:bodyPr>
+          <a:lstStyle/>
+          <a:p>
+            <a:r>
+              <a:rPr sz="2000" b="1"/>
+              <a:t>Fig. 14. National wealth: CWON official vs intangible-adjusted produced capital (2019).</a:t>
+            </a:r>
+          </a:p>
+        </p:txBody>
+      </p:sp>
+      <p:pic>
+        <p:nvPicPr>
+          <p:cNvPr id="3" name="Picture 2" descr="fig14_counterfactual_wealth_en.png"/>
           <p:cNvPicPr>
             <a:picLocks noChangeAspect="1"/>
           </p:cNvPicPr>

</xml_diff>